<commit_message>
Name AI혁신센터 and D&AX부문 in Tech organization boxes
Co-Authored-By: Claude Opus 5.5 <noreply@anthropic.com>
Claude-Session: https://claude.ai/code/session_014bmYQ2fMPYk9mSnunBW5W4
</commit_message>
<xml_diff>
--- a/27_중점과제_FDE_대내사업확대_v3.pptx
+++ b/27_중점과제_FDE_대내사업확대_v3.pptx
@@ -2891,6 +2891,20 @@
                   <a:srgbClr val="262626"/>
                 </a:solidFill>
               </a:rPr>
+              <a:t>AI혁신센터</a:t>
+            </a:r>
+            <a:endParaRPr lang="en-US" sz="1000" dirty="0"/>
+          </a:p>
+          <a:p>
+            <a:pPr algn="ctr" indent="0" marL="0">
+              <a:buNone/>
+            </a:pPr>
+            <a:r>
+              <a:rPr lang="en-US" sz="750" b="1" dirty="0">
+                <a:solidFill>
+                  <a:srgbClr val="7F7F7F"/>
+                </a:solidFill>
+              </a:rPr>
               <a:t>AI Agent 개발</a:t>
             </a:r>
             <a:endParaRPr lang="en-US" sz="1000" dirty="0"/>
@@ -2931,6 +2945,20 @@
               <a:rPr lang="en-US" sz="1000" b="1" dirty="0">
                 <a:solidFill>
                   <a:srgbClr val="262626"/>
+                </a:solidFill>
+              </a:rPr>
+              <a:t>D&amp;AX부문</a:t>
+            </a:r>
+            <a:endParaRPr lang="en-US" sz="1000" dirty="0"/>
+          </a:p>
+          <a:p>
+            <a:pPr algn="ctr" indent="0" marL="0">
+              <a:buNone/>
+            </a:pPr>
+            <a:r>
+              <a:rPr lang="en-US" sz="750" b="1" dirty="0">
+                <a:solidFill>
+                  <a:srgbClr val="7F7F7F"/>
                 </a:solidFill>
               </a:rPr>
               <a:t>데이터·Legacy 연동</a:t>

</xml_diff>

<commit_message>
Replace group-rollout cylinder with Tech sourcing option comparison
Co-Authored-By: Claude Opus 5.5 <noreply@anthropic.com>
Claude-Session: https://claude.ai/code/session_014bmYQ2fMPYk9mSnunBW5W4
</commit_message>
<xml_diff>
--- a/27_중점과제_FDE_대내사업확대_v3.pptx
+++ b/27_중점과제_FDE_대내사업확대_v3.pptx
@@ -2803,7 +2803,7 @@
         <p:spPr>
           <a:xfrm>
             <a:off x="8586216" y="4416552"/>
-            <a:ext cx="1463040" cy="237744"/>
+            <a:ext cx="3200400" cy="237744"/>
           </a:xfrm>
           <a:prstGeom prst="rect">
             <a:avLst/>
@@ -2824,7 +2824,7 @@
                   <a:srgbClr val="262626"/>
                 </a:solidFill>
               </a:rPr>
-              <a:t>구현 (Tech 조직)</a:t>
+              <a:t>구현 (Tech 조직) : 확보 방안 비교</a:t>
             </a:r>
             <a:endParaRPr lang="en-US" sz="1000" dirty="0"/>
           </a:p>
@@ -2839,7 +2839,7 @@
         <p:spPr>
           <a:xfrm>
             <a:off x="8321040" y="4690872"/>
-            <a:ext cx="1508760" cy="896112"/>
+            <a:ext cx="3483864" cy="896112"/>
           </a:xfrm>
           <a:prstGeom prst="rect">
             <a:avLst/>
@@ -2857,14 +2857,14 @@
       </p:sp>
       <p:sp>
         <p:nvSpPr>
-          <p:cNvPr id="52" name="Text 50"/>
-          <p:cNvSpPr txBox="1"/>
-          <p:nvPr/>
-        </p:nvSpPr>
-        <p:spPr>
-          <a:xfrm>
-            <a:off x="8385048" y="4745736"/>
-            <a:ext cx="1380744" cy="365760"/>
+          <p:cNvPr id="52" name="옵션 1"/>
+          <p:cNvSpPr/>
+          <p:nvPr/>
+        </p:nvSpPr>
+        <p:spPr>
+          <a:xfrm>
+            <a:off x="8375904" y="4745736"/>
+            <a:ext cx="1645920" cy="786384"/>
           </a:xfrm>
           <a:prstGeom prst="rect">
             <a:avLst/>
@@ -2876,8 +2876,29 @@
             <a:solidFill>
               <a:srgbClr val="A6A6A6"/>
             </a:solidFill>
+            <a:prstDash val="solid"/>
           </a:ln>
         </p:spPr>
+      </p:sp>
+      <p:sp>
+        <p:nvSpPr>
+          <p:cNvPr id="53" name="Text 51"/>
+          <p:cNvSpPr txBox="1"/>
+          <p:nvPr/>
+        </p:nvSpPr>
+        <p:spPr>
+          <a:xfrm>
+            <a:off x="8375904" y="4745736"/>
+            <a:ext cx="1645920" cy="182880"/>
+          </a:xfrm>
+          <a:prstGeom prst="rect">
+            <a:avLst/>
+          </a:prstGeom>
+          <a:solidFill>
+            <a:srgbClr val="595959"/>
+          </a:solidFill>
+          <a:ln/>
+        </p:spPr>
         <p:txBody>
           <a:bodyPr wrap="square" lIns="0" tIns="0" rIns="0" bIns="0" rtlCol="0" anchor="ctr"/>
           <a:lstStyle/>
@@ -2886,41 +2907,124 @@
               <a:buNone/>
             </a:pPr>
             <a:r>
-              <a:rPr lang="en-US" sz="1000" b="1" dirty="0">
+              <a:rPr lang="en-US" sz="850" b="1" dirty="0">
+                <a:solidFill>
+                  <a:srgbClr val="FFFFFF"/>
+                </a:solidFill>
+              </a:rPr>
+              <a:t>1안 : 경력 채용</a:t>
+            </a:r>
+            <a:endParaRPr lang="en-US" sz="850" dirty="0"/>
+          </a:p>
+        </p:txBody>
+      </p:sp>
+      <p:sp>
+        <p:nvSpPr>
+          <p:cNvPr id="54" name="Text 52"/>
+          <p:cNvSpPr txBox="1"/>
+          <p:nvPr/>
+        </p:nvSpPr>
+        <p:spPr>
+          <a:xfrm>
+            <a:off x="8375904" y="4946904"/>
+            <a:ext cx="1645920" cy="347472"/>
+          </a:xfrm>
+          <a:prstGeom prst="rect">
+            <a:avLst/>
+          </a:prstGeom>
+          <a:noFill/>
+          <a:ln/>
+        </p:spPr>
+        <p:txBody>
+          <a:bodyPr wrap="square" lIns="0" tIns="0" rIns="0" bIns="0" rtlCol="0" anchor="ctr"/>
+          <a:lstStyle/>
+          <a:p>
+            <a:pPr algn="ctr" indent="0" marL="0">
+              <a:buNone/>
+            </a:pPr>
+            <a:r>
+              <a:rPr lang="en-US" sz="900" b="1" dirty="0">
                 <a:solidFill>
                   <a:srgbClr val="262626"/>
                 </a:solidFill>
               </a:rPr>
-              <a:t>AI혁신센터</a:t>
-            </a:r>
-            <a:endParaRPr lang="en-US" sz="1000" dirty="0"/>
+              <a:t>AI 엔지니어 2명 ('27)</a:t>
+            </a:r>
+            <a:endParaRPr lang="en-US" sz="900" dirty="0"/>
           </a:p>
           <a:p>
             <a:pPr algn="ctr" indent="0" marL="0">
               <a:buNone/>
             </a:pPr>
             <a:r>
+              <a:rPr lang="en-US" sz="750" dirty="0">
+                <a:solidFill>
+                  <a:srgbClr val="7F7F7F"/>
+                </a:solidFill>
+              </a:rPr>
+              <a:t>MVP 구현 · 협업 연결</a:t>
+            </a:r>
+            <a:endParaRPr lang="en-US" sz="900" dirty="0"/>
+          </a:p>
+        </p:txBody>
+      </p:sp>
+      <p:sp>
+        <p:nvSpPr>
+          <p:cNvPr id="55" name="Text 53"/>
+          <p:cNvSpPr txBox="1"/>
+          <p:nvPr/>
+        </p:nvSpPr>
+        <p:spPr>
+          <a:xfrm>
+            <a:off x="8375904" y="5321808"/>
+            <a:ext cx="1645920" cy="182880"/>
+          </a:xfrm>
+          <a:prstGeom prst="rect">
+            <a:avLst/>
+          </a:prstGeom>
+          <a:noFill/>
+          <a:ln/>
+        </p:spPr>
+        <p:txBody>
+          <a:bodyPr wrap="square" lIns="0" tIns="0" rIns="0" bIns="0" rtlCol="0" anchor="ctr"/>
+          <a:lstStyle/>
+          <a:p>
+            <a:pPr algn="ctr" indent="0" marL="0">
+              <a:buNone/>
+            </a:pPr>
+            <a:r>
               <a:rPr lang="en-US" sz="750" b="1" dirty="0">
                 <a:solidFill>
-                  <a:srgbClr val="7F7F7F"/>
-                </a:solidFill>
-              </a:rPr>
-              <a:t>AI Agent 개발</a:t>
-            </a:r>
-            <a:endParaRPr lang="en-US" sz="1000" dirty="0"/>
-          </a:p>
-        </p:txBody>
-      </p:sp>
-      <p:sp>
-        <p:nvSpPr>
-          <p:cNvPr id="53" name="Text 51"/>
-          <p:cNvSpPr txBox="1"/>
-          <p:nvPr/>
-        </p:nvSpPr>
-        <p:spPr>
-          <a:xfrm>
-            <a:off x="8385048" y="5166360"/>
-            <a:ext cx="1380744" cy="365760"/>
+                  <a:srgbClr val="2E5C8A"/>
+                </a:solidFill>
+              </a:rPr>
+              <a:t>(+) 노하우 내재화</a:t>
+            </a:r>
+            <a:pPr algn="ctr" indent="0" marL="0">
+              <a:buNone/>
+            </a:pPr>
+            <a:r>
+              <a:rPr lang="en-US" sz="750" b="1" dirty="0">
+                <a:solidFill>
+                  <a:srgbClr val="C0392B"/>
+                </a:solidFill>
+              </a:rPr>
+              <a:t>  (−) 채용 기간</a:t>
+            </a:r>
+            <a:endParaRPr lang="en-US" sz="750" dirty="0"/>
+          </a:p>
+        </p:txBody>
+      </p:sp>
+      <p:sp>
+        <p:nvSpPr>
+          <p:cNvPr id="56" name="옵션 2"/>
+          <p:cNvSpPr/>
+          <p:nvPr/>
+        </p:nvSpPr>
+        <p:spPr>
+          <a:xfrm>
+            <a:off x="10076688" y="4745736"/>
+            <a:ext cx="1645920" cy="786384"/>
           </a:xfrm>
           <a:prstGeom prst="rect">
             <a:avLst/>
@@ -2932,8 +3036,29 @@
             <a:solidFill>
               <a:srgbClr val="A6A6A6"/>
             </a:solidFill>
+            <a:prstDash val="solid"/>
           </a:ln>
         </p:spPr>
+      </p:sp>
+      <p:sp>
+        <p:nvSpPr>
+          <p:cNvPr id="57" name="Text 55"/>
+          <p:cNvSpPr txBox="1"/>
+          <p:nvPr/>
+        </p:nvSpPr>
+        <p:spPr>
+          <a:xfrm>
+            <a:off x="10076688" y="4745736"/>
+            <a:ext cx="1645920" cy="182880"/>
+          </a:xfrm>
+          <a:prstGeom prst="rect">
+            <a:avLst/>
+          </a:prstGeom>
+          <a:solidFill>
+            <a:srgbClr val="595959"/>
+          </a:solidFill>
+          <a:ln/>
+        </p:spPr>
         <p:txBody>
           <a:bodyPr wrap="square" lIns="0" tIns="0" rIns="0" bIns="0" rtlCol="0" anchor="ctr"/>
           <a:lstStyle/>
@@ -2942,34 +3067,117 @@
               <a:buNone/>
             </a:pPr>
             <a:r>
-              <a:rPr lang="en-US" sz="1000" b="1" dirty="0">
+              <a:rPr lang="en-US" sz="850" b="1" dirty="0">
+                <a:solidFill>
+                  <a:srgbClr val="FFFFFF"/>
+                </a:solidFill>
+              </a:rPr>
+              <a:t>2안 : 유관부서 협업</a:t>
+            </a:r>
+            <a:endParaRPr lang="en-US" sz="850" dirty="0"/>
+          </a:p>
+        </p:txBody>
+      </p:sp>
+      <p:sp>
+        <p:nvSpPr>
+          <p:cNvPr id="58" name="Text 56"/>
+          <p:cNvSpPr txBox="1"/>
+          <p:nvPr/>
+        </p:nvSpPr>
+        <p:spPr>
+          <a:xfrm>
+            <a:off x="10076688" y="4946904"/>
+            <a:ext cx="1645920" cy="347472"/>
+          </a:xfrm>
+          <a:prstGeom prst="rect">
+            <a:avLst/>
+          </a:prstGeom>
+          <a:noFill/>
+          <a:ln/>
+        </p:spPr>
+        <p:txBody>
+          <a:bodyPr wrap="square" lIns="0" tIns="0" rIns="0" bIns="0" rtlCol="0" anchor="ctr"/>
+          <a:lstStyle/>
+          <a:p>
+            <a:pPr algn="ctr" indent="0" marL="0">
+              <a:buNone/>
+            </a:pPr>
+            <a:r>
+              <a:rPr lang="en-US" sz="900" b="1" dirty="0">
                 <a:solidFill>
                   <a:srgbClr val="262626"/>
                 </a:solidFill>
               </a:rPr>
-              <a:t>D&amp;AX부문</a:t>
-            </a:r>
-            <a:endParaRPr lang="en-US" sz="1000" dirty="0"/>
+              <a:t>AI혁신센터·D&amp;AX부문</a:t>
+            </a:r>
+            <a:endParaRPr lang="en-US" sz="900" dirty="0"/>
           </a:p>
           <a:p>
             <a:pPr algn="ctr" indent="0" marL="0">
               <a:buNone/>
             </a:pPr>
             <a:r>
+              <a:rPr lang="en-US" sz="750" dirty="0">
+                <a:solidFill>
+                  <a:srgbClr val="7F7F7F"/>
+                </a:solidFill>
+              </a:rPr>
+              <a:t>AI Agent · Legacy 연동</a:t>
+            </a:r>
+            <a:endParaRPr lang="en-US" sz="900" dirty="0"/>
+          </a:p>
+        </p:txBody>
+      </p:sp>
+      <p:sp>
+        <p:nvSpPr>
+          <p:cNvPr id="59" name="Text 57"/>
+          <p:cNvSpPr txBox="1"/>
+          <p:nvPr/>
+        </p:nvSpPr>
+        <p:spPr>
+          <a:xfrm>
+            <a:off x="10076688" y="5321808"/>
+            <a:ext cx="1645920" cy="182880"/>
+          </a:xfrm>
+          <a:prstGeom prst="rect">
+            <a:avLst/>
+          </a:prstGeom>
+          <a:noFill/>
+          <a:ln/>
+        </p:spPr>
+        <p:txBody>
+          <a:bodyPr wrap="square" lIns="0" tIns="0" rIns="0" bIns="0" rtlCol="0" anchor="ctr"/>
+          <a:lstStyle/>
+          <a:p>
+            <a:pPr algn="ctr" indent="0" marL="0">
+              <a:buNone/>
+            </a:pPr>
+            <a:r>
               <a:rPr lang="en-US" sz="750" b="1" dirty="0">
                 <a:solidFill>
-                  <a:srgbClr val="7F7F7F"/>
-                </a:solidFill>
-              </a:rPr>
-              <a:t>데이터·Legacy 연동</a:t>
-            </a:r>
-            <a:endParaRPr lang="en-US" sz="1000" dirty="0"/>
-          </a:p>
-        </p:txBody>
-      </p:sp>
-      <p:sp>
-        <p:nvSpPr>
-          <p:cNvPr id="54" name="점선 화살표"/>
+                  <a:srgbClr val="2E5C8A"/>
+                </a:solidFill>
+              </a:rPr>
+              <a:t>(+) 즉시 투입</a:t>
+            </a:r>
+            <a:pPr algn="ctr" indent="0" marL="0">
+              <a:buNone/>
+            </a:pPr>
+            <a:r>
+              <a:rPr lang="en-US" sz="750" b="1" dirty="0">
+                <a:solidFill>
+                  <a:srgbClr val="C0392B"/>
+                </a:solidFill>
+              </a:rPr>
+              <a:t>  (−) 일정 조율</a:t>
+            </a:r>
+            <a:endParaRPr lang="en-US" sz="750" dirty="0"/>
+          </a:p>
+        </p:txBody>
+      </p:sp>
+      <p:sp>
+        <p:nvSpPr>
+          <p:cNvPr id="60" name="점선 화살표"/>
           <p:cNvSpPr/>
           <p:nvPr/>
         </p:nvSpPr>
@@ -2993,7 +3201,7 @@
       </p:sp>
       <p:sp>
         <p:nvSpPr>
-          <p:cNvPr id="55" name="점선 화살표"/>
+          <p:cNvPr id="61" name="점선 화살표"/>
           <p:cNvSpPr/>
           <p:nvPr/>
         </p:nvSpPr>
@@ -3017,472 +3225,7 @@
       </p:sp>
       <p:sp>
         <p:nvSpPr>
-          <p:cNvPr id="56" name="점선 화살표"/>
-          <p:cNvSpPr/>
-          <p:nvPr/>
-        </p:nvSpPr>
-        <p:spPr>
-          <a:xfrm>
-            <a:off x="9848088" y="4873752"/>
-            <a:ext cx="374904" cy="0"/>
-          </a:xfrm>
-          <a:prstGeom prst="line">
-            <a:avLst/>
-          </a:prstGeom>
-          <a:noFill/>
-          <a:ln w="12700">
-            <a:solidFill>
-              <a:srgbClr val="8C8C8C"/>
-            </a:solidFill>
-            <a:prstDash val="dash"/>
-            <a:tailEnd type="triangle"/>
-          </a:ln>
-        </p:spPr>
-      </p:sp>
-      <p:sp>
-        <p:nvSpPr>
-          <p:cNvPr id="57" name="점선 화살표"/>
-          <p:cNvSpPr/>
-          <p:nvPr/>
-        </p:nvSpPr>
-        <p:spPr>
-          <a:xfrm>
-            <a:off x="9848088" y="5422392"/>
-            <a:ext cx="374904" cy="0"/>
-          </a:xfrm>
-          <a:prstGeom prst="line">
-            <a:avLst/>
-          </a:prstGeom>
-          <a:noFill/>
-          <a:ln w="12700">
-            <a:solidFill>
-              <a:srgbClr val="8C8C8C"/>
-            </a:solidFill>
-            <a:prstDash val="dash"/>
-            <a:tailEnd type="triangle"/>
-          </a:ln>
-        </p:spPr>
-      </p:sp>
-      <p:sp>
-        <p:nvSpPr>
-          <p:cNvPr id="58" name="번호 3"/>
-          <p:cNvSpPr/>
-          <p:nvPr/>
-        </p:nvSpPr>
-        <p:spPr>
-          <a:xfrm>
-            <a:off x="9939528" y="4983480"/>
-            <a:ext cx="201168" cy="201168"/>
-          </a:xfrm>
-          <a:prstGeom prst="ellipse">
-            <a:avLst/>
-          </a:prstGeom>
-          <a:solidFill>
-            <a:srgbClr val="262626"/>
-          </a:solidFill>
-          <a:ln w="12700">
-            <a:solidFill>
-              <a:srgbClr val="262626"/>
-            </a:solidFill>
-            <a:prstDash val="solid"/>
-          </a:ln>
-        </p:spPr>
-      </p:sp>
-      <p:sp>
-        <p:nvSpPr>
-          <p:cNvPr id="59" name="Text 57"/>
-          <p:cNvSpPr txBox="1"/>
-          <p:nvPr/>
-        </p:nvSpPr>
-        <p:spPr>
-          <a:xfrm>
-            <a:off x="9939528" y="4983480"/>
-            <a:ext cx="201168" cy="201168"/>
-          </a:xfrm>
-          <a:prstGeom prst="rect">
-            <a:avLst/>
-          </a:prstGeom>
-          <a:noFill/>
-          <a:ln/>
-        </p:spPr>
-        <p:txBody>
-          <a:bodyPr wrap="square" lIns="0" tIns="0" rIns="0" bIns="0" rtlCol="0" anchor="ctr"/>
-          <a:lstStyle/>
-          <a:p>
-            <a:pPr algn="ctr" indent="0" marL="0">
-              <a:buNone/>
-            </a:pPr>
-            <a:r>
-              <a:rPr lang="en-US" sz="900" b="1" dirty="0">
-                <a:solidFill>
-                  <a:srgbClr val="FFFFFF"/>
-                </a:solidFill>
-              </a:rPr>
-              <a:t>3</a:t>
-            </a:r>
-            <a:endParaRPr lang="en-US" sz="900" dirty="0"/>
-          </a:p>
-        </p:txBody>
-      </p:sp>
-      <p:sp>
-        <p:nvSpPr>
-          <p:cNvPr id="60" name="Text 58"/>
-          <p:cNvSpPr txBox="1"/>
-          <p:nvPr/>
-        </p:nvSpPr>
-        <p:spPr>
-          <a:xfrm>
-            <a:off x="9811512" y="5193792"/>
-            <a:ext cx="457200" cy="128016"/>
-          </a:xfrm>
-          <a:prstGeom prst="rect">
-            <a:avLst/>
-          </a:prstGeom>
-          <a:noFill/>
-          <a:ln/>
-        </p:spPr>
-        <p:txBody>
-          <a:bodyPr wrap="square" lIns="0" tIns="0" rIns="0" bIns="0" rtlCol="0" anchor="ctr"/>
-          <a:lstStyle/>
-          <a:p>
-            <a:pPr algn="ctr" indent="0" marL="0">
-              <a:buNone/>
-            </a:pPr>
-            <a:r>
-              <a:rPr lang="en-US" sz="700" b="1" dirty="0">
-                <a:solidFill>
-                  <a:srgbClr val="262626"/>
-                </a:solidFill>
-              </a:rPr>
-              <a:t>운영 이관</a:t>
-            </a:r>
-            <a:endParaRPr lang="en-US" sz="700" dirty="0"/>
-          </a:p>
-        </p:txBody>
-      </p:sp>
-      <p:sp>
-        <p:nvSpPr>
-          <p:cNvPr id="61" name="번호 4"/>
-          <p:cNvSpPr/>
-          <p:nvPr/>
-        </p:nvSpPr>
-        <p:spPr>
-          <a:xfrm>
-            <a:off x="10314432" y="4434840"/>
-            <a:ext cx="201168" cy="201168"/>
-          </a:xfrm>
-          <a:prstGeom prst="ellipse">
-            <a:avLst/>
-          </a:prstGeom>
-          <a:solidFill>
-            <a:srgbClr val="262626"/>
-          </a:solidFill>
-          <a:ln w="12700">
-            <a:solidFill>
-              <a:srgbClr val="262626"/>
-            </a:solidFill>
-            <a:prstDash val="solid"/>
-          </a:ln>
-        </p:spPr>
-      </p:sp>
-      <p:sp>
-        <p:nvSpPr>
-          <p:cNvPr id="62" name="Text 60"/>
-          <p:cNvSpPr txBox="1"/>
-          <p:nvPr/>
-        </p:nvSpPr>
-        <p:spPr>
-          <a:xfrm>
-            <a:off x="10314432" y="4434840"/>
-            <a:ext cx="201168" cy="201168"/>
-          </a:xfrm>
-          <a:prstGeom prst="rect">
-            <a:avLst/>
-          </a:prstGeom>
-          <a:noFill/>
-          <a:ln/>
-        </p:spPr>
-        <p:txBody>
-          <a:bodyPr wrap="square" lIns="0" tIns="0" rIns="0" bIns="0" rtlCol="0" anchor="ctr"/>
-          <a:lstStyle/>
-          <a:p>
-            <a:pPr algn="ctr" indent="0" marL="0">
-              <a:buNone/>
-            </a:pPr>
-            <a:r>
-              <a:rPr lang="en-US" sz="900" b="1" dirty="0">
-                <a:solidFill>
-                  <a:srgbClr val="FFFFFF"/>
-                </a:solidFill>
-              </a:rPr>
-              <a:t>4</a:t>
-            </a:r>
-            <a:endParaRPr lang="en-US" sz="900" dirty="0"/>
-          </a:p>
-        </p:txBody>
-      </p:sp>
-      <p:sp>
-        <p:nvSpPr>
-          <p:cNvPr id="63" name="Text 61"/>
-          <p:cNvSpPr txBox="1"/>
-          <p:nvPr/>
-        </p:nvSpPr>
-        <p:spPr>
-          <a:xfrm>
-            <a:off x="10552176" y="4416552"/>
-            <a:ext cx="1463040" cy="237744"/>
-          </a:xfrm>
-          <a:prstGeom prst="rect">
-            <a:avLst/>
-          </a:prstGeom>
-          <a:noFill/>
-          <a:ln/>
-        </p:spPr>
-        <p:txBody>
-          <a:bodyPr wrap="square" lIns="0" tIns="0" rIns="0" bIns="0" rtlCol="0" anchor="ctr"/>
-          <a:lstStyle/>
-          <a:p>
-            <a:pPr indent="0" marL="0">
-              <a:buNone/>
-            </a:pPr>
-            <a:r>
-              <a:rPr lang="en-US" sz="1000" b="1" dirty="0">
-                <a:solidFill>
-                  <a:srgbClr val="262626"/>
-                </a:solidFill>
-              </a:rPr>
-              <a:t>그룹사 확산</a:t>
-            </a:r>
-            <a:endParaRPr lang="en-US" sz="1000" dirty="0"/>
-          </a:p>
-        </p:txBody>
-      </p:sp>
-      <p:sp>
-        <p:nvSpPr>
-          <p:cNvPr id="64" name="그룹사 원통"/>
-          <p:cNvSpPr/>
-          <p:nvPr/>
-        </p:nvSpPr>
-        <p:spPr>
-          <a:xfrm>
-            <a:off x="10268712" y="4690872"/>
-            <a:ext cx="1536192" cy="896112"/>
-          </a:xfrm>
-          <a:prstGeom prst="can">
-            <a:avLst/>
-          </a:prstGeom>
-          <a:solidFill>
-            <a:srgbClr val="FFFFFF"/>
-          </a:solidFill>
-          <a:ln w="9525">
-            <a:solidFill>
-              <a:srgbClr val="A6A6A6"/>
-            </a:solidFill>
-            <a:prstDash val="solid"/>
-          </a:ln>
-        </p:spPr>
-      </p:sp>
-      <p:sp>
-        <p:nvSpPr>
-          <p:cNvPr id="65" name="Text 63"/>
-          <p:cNvSpPr txBox="1"/>
-          <p:nvPr/>
-        </p:nvSpPr>
-        <p:spPr>
-          <a:xfrm>
-            <a:off x="10268712" y="4892040"/>
-            <a:ext cx="1536192" cy="201168"/>
-          </a:xfrm>
-          <a:prstGeom prst="rect">
-            <a:avLst/>
-          </a:prstGeom>
-          <a:noFill/>
-          <a:ln/>
-        </p:spPr>
-        <p:txBody>
-          <a:bodyPr wrap="square" lIns="0" tIns="0" rIns="0" bIns="0" rtlCol="0" anchor="ctr"/>
-          <a:lstStyle/>
-          <a:p>
-            <a:pPr algn="ctr" indent="0" marL="0">
-              <a:buNone/>
-            </a:pPr>
-            <a:r>
-              <a:rPr lang="en-US" sz="950" b="1" dirty="0">
-                <a:solidFill>
-                  <a:srgbClr val="262626"/>
-                </a:solidFill>
-              </a:rPr>
-              <a:t>그룹사 현장</a:t>
-            </a:r>
-            <a:endParaRPr lang="en-US" sz="950" dirty="0"/>
-          </a:p>
-        </p:txBody>
-      </p:sp>
-      <p:sp>
-        <p:nvSpPr>
-          <p:cNvPr id="66" name="Text 64"/>
-          <p:cNvSpPr txBox="1"/>
-          <p:nvPr/>
-        </p:nvSpPr>
-        <p:spPr>
-          <a:xfrm>
-            <a:off x="10378440" y="5129784"/>
-            <a:ext cx="411480" cy="219456"/>
-          </a:xfrm>
-          <a:prstGeom prst="rect">
-            <a:avLst/>
-          </a:prstGeom>
-          <a:solidFill>
-            <a:srgbClr val="F2F2F2"/>
-          </a:solidFill>
-          <a:ln w="6350">
-            <a:solidFill>
-              <a:srgbClr val="D9D9D9"/>
-            </a:solidFill>
-          </a:ln>
-        </p:spPr>
-        <p:txBody>
-          <a:bodyPr wrap="square" lIns="0" tIns="0" rIns="0" bIns="0" rtlCol="0" anchor="ctr"/>
-          <a:lstStyle/>
-          <a:p>
-            <a:pPr algn="ctr" indent="0" marL="0">
-              <a:buNone/>
-            </a:pPr>
-            <a:r>
-              <a:rPr lang="en-US" sz="850" b="1" dirty="0">
-                <a:solidFill>
-                  <a:srgbClr val="262626"/>
-                </a:solidFill>
-              </a:rPr>
-              <a:t>호텔</a:t>
-            </a:r>
-            <a:endParaRPr lang="en-US" sz="850" dirty="0"/>
-          </a:p>
-        </p:txBody>
-      </p:sp>
-      <p:sp>
-        <p:nvSpPr>
-          <p:cNvPr id="67" name="Text 65"/>
-          <p:cNvSpPr txBox="1"/>
-          <p:nvPr/>
-        </p:nvSpPr>
-        <p:spPr>
-          <a:xfrm>
-            <a:off x="10826496" y="5129784"/>
-            <a:ext cx="411480" cy="219456"/>
-          </a:xfrm>
-          <a:prstGeom prst="rect">
-            <a:avLst/>
-          </a:prstGeom>
-          <a:solidFill>
-            <a:srgbClr val="F2F2F2"/>
-          </a:solidFill>
-          <a:ln w="6350">
-            <a:solidFill>
-              <a:srgbClr val="D9D9D9"/>
-            </a:solidFill>
-          </a:ln>
-        </p:spPr>
-        <p:txBody>
-          <a:bodyPr wrap="square" lIns="0" tIns="0" rIns="0" bIns="0" rtlCol="0" anchor="ctr"/>
-          <a:lstStyle/>
-          <a:p>
-            <a:pPr algn="ctr" indent="0" marL="0">
-              <a:buNone/>
-            </a:pPr>
-            <a:r>
-              <a:rPr lang="en-US" sz="850" b="1" dirty="0">
-                <a:solidFill>
-                  <a:srgbClr val="262626"/>
-                </a:solidFill>
-              </a:rPr>
-              <a:t>백화점</a:t>
-            </a:r>
-            <a:endParaRPr lang="en-US" sz="850" dirty="0"/>
-          </a:p>
-        </p:txBody>
-      </p:sp>
-      <p:sp>
-        <p:nvSpPr>
-          <p:cNvPr id="68" name="Text 66"/>
-          <p:cNvSpPr txBox="1"/>
-          <p:nvPr/>
-        </p:nvSpPr>
-        <p:spPr>
-          <a:xfrm>
-            <a:off x="11274552" y="5129784"/>
-            <a:ext cx="411480" cy="219456"/>
-          </a:xfrm>
-          <a:prstGeom prst="rect">
-            <a:avLst/>
-          </a:prstGeom>
-          <a:solidFill>
-            <a:srgbClr val="F2F2F2"/>
-          </a:solidFill>
-          <a:ln w="6350">
-            <a:solidFill>
-              <a:srgbClr val="D9D9D9"/>
-            </a:solidFill>
-          </a:ln>
-        </p:spPr>
-        <p:txBody>
-          <a:bodyPr wrap="square" lIns="0" tIns="0" rIns="0" bIns="0" rtlCol="0" anchor="ctr"/>
-          <a:lstStyle/>
-          <a:p>
-            <a:pPr algn="ctr" indent="0" marL="0">
-              <a:buNone/>
-            </a:pPr>
-            <a:r>
-              <a:rPr lang="en-US" sz="850" b="1" dirty="0">
-                <a:solidFill>
-                  <a:srgbClr val="262626"/>
-                </a:solidFill>
-              </a:rPr>
-              <a:t>…</a:t>
-            </a:r>
-            <a:endParaRPr lang="en-US" sz="850" dirty="0"/>
-          </a:p>
-        </p:txBody>
-      </p:sp>
-      <p:sp>
-        <p:nvSpPr>
-          <p:cNvPr id="69" name="Text 67"/>
-          <p:cNvSpPr txBox="1"/>
-          <p:nvPr/>
-        </p:nvSpPr>
-        <p:spPr>
-          <a:xfrm>
-            <a:off x="10268712" y="5376672"/>
-            <a:ext cx="1536192" cy="182880"/>
-          </a:xfrm>
-          <a:prstGeom prst="rect">
-            <a:avLst/>
-          </a:prstGeom>
-          <a:noFill/>
-          <a:ln/>
-        </p:spPr>
-        <p:txBody>
-          <a:bodyPr wrap="square" lIns="0" tIns="0" rIns="0" bIns="0" rtlCol="0" anchor="ctr"/>
-          <a:lstStyle/>
-          <a:p>
-            <a:pPr algn="ctr" indent="0" marL="0">
-              <a:buNone/>
-            </a:pPr>
-            <a:r>
-              <a:rPr lang="en-US" sz="800" b="1" dirty="0">
-                <a:solidFill>
-                  <a:srgbClr val="2E5C8A"/>
-                </a:solidFill>
-              </a:rPr>
-              <a:t>MVP → 구축사업</a:t>
-            </a:r>
-            <a:endParaRPr lang="en-US" sz="800" dirty="0"/>
-          </a:p>
-        </p:txBody>
-      </p:sp>
-      <p:sp>
-        <p:nvSpPr>
-          <p:cNvPr id="70" name="머리표 기대효과"/>
+          <p:cNvPr id="62" name="머리표 기대효과"/>
           <p:cNvSpPr/>
           <p:nvPr/>
         </p:nvSpPr>
@@ -3514,7 +3257,7 @@
       </p:sp>
       <p:sp>
         <p:nvSpPr>
-          <p:cNvPr id="71" name="Text 69"/>
+          <p:cNvPr id="63" name="Text 61"/>
           <p:cNvSpPr txBox="1"/>
           <p:nvPr/>
         </p:nvSpPr>
@@ -3550,7 +3293,7 @@
       </p:sp>
       <p:sp>
         <p:nvSpPr>
-          <p:cNvPr id="72" name="Text 70"/>
+          <p:cNvPr id="64" name="Text 62"/>
           <p:cNvSpPr txBox="1"/>
           <p:nvPr/>
         </p:nvSpPr>
@@ -3588,7 +3331,7 @@
       </p:sp>
       <p:sp>
         <p:nvSpPr>
-          <p:cNvPr id="73" name="Text 71"/>
+          <p:cNvPr id="65" name="Text 63"/>
           <p:cNvSpPr txBox="1"/>
           <p:nvPr/>
         </p:nvSpPr>
@@ -3624,7 +3367,7 @@
       </p:sp>
       <p:sp>
         <p:nvSpPr>
-          <p:cNvPr id="74" name="Text 72"/>
+          <p:cNvPr id="66" name="Text 64"/>
           <p:cNvSpPr txBox="1"/>
           <p:nvPr/>
         </p:nvSpPr>
@@ -3662,7 +3405,7 @@
       </p:sp>
       <p:sp>
         <p:nvSpPr>
-          <p:cNvPr id="75" name="Text 73"/>
+          <p:cNvPr id="67" name="Text 65"/>
           <p:cNvSpPr txBox="1"/>
           <p:nvPr/>
         </p:nvSpPr>
@@ -3698,7 +3441,7 @@
       </p:sp>
       <p:sp>
         <p:nvSpPr>
-          <p:cNvPr id="76" name="Text 74"/>
+          <p:cNvPr id="68" name="Text 66"/>
           <p:cNvSpPr txBox="1"/>
           <p:nvPr/>
         </p:nvSpPr>
@@ -3736,7 +3479,7 @@
       </p:sp>
       <p:sp>
         <p:nvSpPr>
-          <p:cNvPr id="77" name="Text 75"/>
+          <p:cNvPr id="69" name="Text 67"/>
           <p:cNvSpPr txBox="1"/>
           <p:nvPr/>
         </p:nvSpPr>

</xml_diff>

<commit_message>
Restructure TF diagram: stacked 1안/2안 Tech options, recommendation, 운영 이관 to 그룹사
Co-Authored-By: Claude Opus 5.5 <noreply@anthropic.com>
Claude-Session: https://claude.ai/code/session_014bmYQ2fMPYk9mSnunBW5W4
</commit_message>
<xml_diff>
--- a/27_중점과제_FDE_대내사업확대_v3.pptx
+++ b/27_중점과제_FDE_대내사업확대_v3.pptx
@@ -2439,7 +2439,7 @@
         </p:nvSpPr>
         <p:spPr>
           <a:xfrm>
-            <a:off x="6336792" y="4105656"/>
+            <a:off x="6336792" y="4069080"/>
             <a:ext cx="155448" cy="155448"/>
           </a:xfrm>
           <a:prstGeom prst="rect">
@@ -2471,7 +2471,7 @@
         </p:nvSpPr>
         <p:spPr>
           <a:xfrm>
-            <a:off x="6565392" y="4041648"/>
+            <a:off x="6565392" y="4005072"/>
             <a:ext cx="5230368" cy="283464"/>
           </a:xfrm>
           <a:prstGeom prst="rect">
@@ -2507,7 +2507,7 @@
         </p:nvSpPr>
         <p:spPr>
           <a:xfrm>
-            <a:off x="6364224" y="4434840"/>
+            <a:off x="6364224" y="4343400"/>
             <a:ext cx="201168" cy="201168"/>
           </a:xfrm>
           <a:prstGeom prst="ellipse">
@@ -2532,7 +2532,7 @@
         </p:nvSpPr>
         <p:spPr>
           <a:xfrm>
-            <a:off x="6364224" y="4434840"/>
+            <a:off x="6364224" y="4343400"/>
             <a:ext cx="201168" cy="201168"/>
           </a:xfrm>
           <a:prstGeom prst="rect">
@@ -2568,7 +2568,7 @@
         </p:nvSpPr>
         <p:spPr>
           <a:xfrm>
-            <a:off x="6601968" y="4416552"/>
+            <a:off x="6601968" y="4325112"/>
             <a:ext cx="1463040" cy="237744"/>
           </a:xfrm>
           <a:prstGeom prst="rect">
@@ -2604,8 +2604,8 @@
         </p:nvSpPr>
         <p:spPr>
           <a:xfrm>
-            <a:off x="6336792" y="4690872"/>
-            <a:ext cx="1691640" cy="896112"/>
+            <a:off x="6336792" y="4599432"/>
+            <a:ext cx="1554480" cy="914400"/>
           </a:xfrm>
           <a:prstGeom prst="rect">
             <a:avLst/>
@@ -2629,8 +2629,8 @@
         </p:nvSpPr>
         <p:spPr>
           <a:xfrm>
-            <a:off x="6400800" y="4745736"/>
-            <a:ext cx="1563624" cy="365760"/>
+            <a:off x="6391656" y="4654296"/>
+            <a:ext cx="1444752" cy="384048"/>
           </a:xfrm>
           <a:prstGeom prst="rect">
             <a:avLst/>
@@ -2685,8 +2685,8 @@
         </p:nvSpPr>
         <p:spPr>
           <a:xfrm>
-            <a:off x="6400800" y="5166360"/>
-            <a:ext cx="1563624" cy="365760"/>
+            <a:off x="6391656" y="5074920"/>
+            <a:ext cx="1444752" cy="384048"/>
           </a:xfrm>
           <a:prstGeom prst="rect">
             <a:avLst/>
@@ -2735,456 +2735,14 @@
       </p:sp>
       <p:sp>
         <p:nvSpPr>
-          <p:cNvPr id="48" name="번호 2"/>
+          <p:cNvPr id="48" name="점선 화살표"/>
           <p:cNvSpPr/>
           <p:nvPr/>
         </p:nvSpPr>
         <p:spPr>
           <a:xfrm>
-            <a:off x="8348472" y="4434840"/>
-            <a:ext cx="201168" cy="201168"/>
-          </a:xfrm>
-          <a:prstGeom prst="ellipse">
-            <a:avLst/>
-          </a:prstGeom>
-          <a:solidFill>
-            <a:srgbClr val="262626"/>
-          </a:solidFill>
-          <a:ln w="12700">
-            <a:solidFill>
-              <a:srgbClr val="262626"/>
-            </a:solidFill>
-            <a:prstDash val="solid"/>
-          </a:ln>
-        </p:spPr>
-      </p:sp>
-      <p:sp>
-        <p:nvSpPr>
-          <p:cNvPr id="49" name="Text 47"/>
-          <p:cNvSpPr txBox="1"/>
-          <p:nvPr/>
-        </p:nvSpPr>
-        <p:spPr>
-          <a:xfrm>
-            <a:off x="8348472" y="4434840"/>
-            <a:ext cx="201168" cy="201168"/>
-          </a:xfrm>
-          <a:prstGeom prst="rect">
-            <a:avLst/>
-          </a:prstGeom>
-          <a:noFill/>
-          <a:ln/>
-        </p:spPr>
-        <p:txBody>
-          <a:bodyPr wrap="square" lIns="0" tIns="0" rIns="0" bIns="0" rtlCol="0" anchor="ctr"/>
-          <a:lstStyle/>
-          <a:p>
-            <a:pPr algn="ctr" indent="0" marL="0">
-              <a:buNone/>
-            </a:pPr>
-            <a:r>
-              <a:rPr lang="en-US" sz="900" b="1" dirty="0">
-                <a:solidFill>
-                  <a:srgbClr val="FFFFFF"/>
-                </a:solidFill>
-              </a:rPr>
-              <a:t>2</a:t>
-            </a:r>
-            <a:endParaRPr lang="en-US" sz="900" dirty="0"/>
-          </a:p>
-        </p:txBody>
-      </p:sp>
-      <p:sp>
-        <p:nvSpPr>
-          <p:cNvPr id="50" name="Text 48"/>
-          <p:cNvSpPr txBox="1"/>
-          <p:nvPr/>
-        </p:nvSpPr>
-        <p:spPr>
-          <a:xfrm>
-            <a:off x="8586216" y="4416552"/>
-            <a:ext cx="3200400" cy="237744"/>
-          </a:xfrm>
-          <a:prstGeom prst="rect">
-            <a:avLst/>
-          </a:prstGeom>
-          <a:noFill/>
-          <a:ln/>
-        </p:spPr>
-        <p:txBody>
-          <a:bodyPr wrap="square" lIns="0" tIns="0" rIns="0" bIns="0" rtlCol="0" anchor="ctr"/>
-          <a:lstStyle/>
-          <a:p>
-            <a:pPr indent="0" marL="0">
-              <a:buNone/>
-            </a:pPr>
-            <a:r>
-              <a:rPr lang="en-US" sz="1000" b="1" dirty="0">
-                <a:solidFill>
-                  <a:srgbClr val="262626"/>
-                </a:solidFill>
-              </a:rPr>
-              <a:t>구현 (Tech 조직) : 확보 방안 비교</a:t>
-            </a:r>
-            <a:endParaRPr lang="en-US" sz="1000" dirty="0"/>
-          </a:p>
-        </p:txBody>
-      </p:sp>
-      <p:sp>
-        <p:nvSpPr>
-          <p:cNvPr id="51" name="Tech 그룹"/>
-          <p:cNvSpPr/>
-          <p:nvPr/>
-        </p:nvSpPr>
-        <p:spPr>
-          <a:xfrm>
-            <a:off x="8321040" y="4690872"/>
-            <a:ext cx="3483864" cy="896112"/>
-          </a:xfrm>
-          <a:prstGeom prst="rect">
-            <a:avLst/>
-          </a:prstGeom>
-          <a:solidFill>
-            <a:srgbClr val="FAFAFA"/>
-          </a:solidFill>
-          <a:ln w="9525">
-            <a:solidFill>
-              <a:srgbClr val="BFBFBF"/>
-            </a:solidFill>
-            <a:prstDash val="solid"/>
-          </a:ln>
-        </p:spPr>
-      </p:sp>
-      <p:sp>
-        <p:nvSpPr>
-          <p:cNvPr id="52" name="옵션 1"/>
-          <p:cNvSpPr/>
-          <p:nvPr/>
-        </p:nvSpPr>
-        <p:spPr>
-          <a:xfrm>
-            <a:off x="8375904" y="4745736"/>
-            <a:ext cx="1645920" cy="786384"/>
-          </a:xfrm>
-          <a:prstGeom prst="rect">
-            <a:avLst/>
-          </a:prstGeom>
-          <a:solidFill>
-            <a:srgbClr val="FFFFFF"/>
-          </a:solidFill>
-          <a:ln w="9525">
-            <a:solidFill>
-              <a:srgbClr val="A6A6A6"/>
-            </a:solidFill>
-            <a:prstDash val="solid"/>
-          </a:ln>
-        </p:spPr>
-      </p:sp>
-      <p:sp>
-        <p:nvSpPr>
-          <p:cNvPr id="53" name="Text 51"/>
-          <p:cNvSpPr txBox="1"/>
-          <p:nvPr/>
-        </p:nvSpPr>
-        <p:spPr>
-          <a:xfrm>
-            <a:off x="8375904" y="4745736"/>
-            <a:ext cx="1645920" cy="182880"/>
-          </a:xfrm>
-          <a:prstGeom prst="rect">
-            <a:avLst/>
-          </a:prstGeom>
-          <a:solidFill>
-            <a:srgbClr val="595959"/>
-          </a:solidFill>
-          <a:ln/>
-        </p:spPr>
-        <p:txBody>
-          <a:bodyPr wrap="square" lIns="0" tIns="0" rIns="0" bIns="0" rtlCol="0" anchor="ctr"/>
-          <a:lstStyle/>
-          <a:p>
-            <a:pPr algn="ctr" indent="0" marL="0">
-              <a:buNone/>
-            </a:pPr>
-            <a:r>
-              <a:rPr lang="en-US" sz="850" b="1" dirty="0">
-                <a:solidFill>
-                  <a:srgbClr val="FFFFFF"/>
-                </a:solidFill>
-              </a:rPr>
-              <a:t>1안 : 경력 채용</a:t>
-            </a:r>
-            <a:endParaRPr lang="en-US" sz="850" dirty="0"/>
-          </a:p>
-        </p:txBody>
-      </p:sp>
-      <p:sp>
-        <p:nvSpPr>
-          <p:cNvPr id="54" name="Text 52"/>
-          <p:cNvSpPr txBox="1"/>
-          <p:nvPr/>
-        </p:nvSpPr>
-        <p:spPr>
-          <a:xfrm>
-            <a:off x="8375904" y="4946904"/>
-            <a:ext cx="1645920" cy="347472"/>
-          </a:xfrm>
-          <a:prstGeom prst="rect">
-            <a:avLst/>
-          </a:prstGeom>
-          <a:noFill/>
-          <a:ln/>
-        </p:spPr>
-        <p:txBody>
-          <a:bodyPr wrap="square" lIns="0" tIns="0" rIns="0" bIns="0" rtlCol="0" anchor="ctr"/>
-          <a:lstStyle/>
-          <a:p>
-            <a:pPr algn="ctr" indent="0" marL="0">
-              <a:buNone/>
-            </a:pPr>
-            <a:r>
-              <a:rPr lang="en-US" sz="900" b="1" dirty="0">
-                <a:solidFill>
-                  <a:srgbClr val="262626"/>
-                </a:solidFill>
-              </a:rPr>
-              <a:t>AI 엔지니어 2명 ('27)</a:t>
-            </a:r>
-            <a:endParaRPr lang="en-US" sz="900" dirty="0"/>
-          </a:p>
-          <a:p>
-            <a:pPr algn="ctr" indent="0" marL="0">
-              <a:buNone/>
-            </a:pPr>
-            <a:r>
-              <a:rPr lang="en-US" sz="750" dirty="0">
-                <a:solidFill>
-                  <a:srgbClr val="7F7F7F"/>
-                </a:solidFill>
-              </a:rPr>
-              <a:t>MVP 구현 · 협업 연결</a:t>
-            </a:r>
-            <a:endParaRPr lang="en-US" sz="900" dirty="0"/>
-          </a:p>
-        </p:txBody>
-      </p:sp>
-      <p:sp>
-        <p:nvSpPr>
-          <p:cNvPr id="55" name="Text 53"/>
-          <p:cNvSpPr txBox="1"/>
-          <p:nvPr/>
-        </p:nvSpPr>
-        <p:spPr>
-          <a:xfrm>
-            <a:off x="8375904" y="5321808"/>
-            <a:ext cx="1645920" cy="182880"/>
-          </a:xfrm>
-          <a:prstGeom prst="rect">
-            <a:avLst/>
-          </a:prstGeom>
-          <a:noFill/>
-          <a:ln/>
-        </p:spPr>
-        <p:txBody>
-          <a:bodyPr wrap="square" lIns="0" tIns="0" rIns="0" bIns="0" rtlCol="0" anchor="ctr"/>
-          <a:lstStyle/>
-          <a:p>
-            <a:pPr algn="ctr" indent="0" marL="0">
-              <a:buNone/>
-            </a:pPr>
-            <a:r>
-              <a:rPr lang="en-US" sz="750" b="1" dirty="0">
-                <a:solidFill>
-                  <a:srgbClr val="2E5C8A"/>
-                </a:solidFill>
-              </a:rPr>
-              <a:t>(+) 노하우 내재화</a:t>
-            </a:r>
-            <a:pPr algn="ctr" indent="0" marL="0">
-              <a:buNone/>
-            </a:pPr>
-            <a:r>
-              <a:rPr lang="en-US" sz="750" b="1" dirty="0">
-                <a:solidFill>
-                  <a:srgbClr val="C0392B"/>
-                </a:solidFill>
-              </a:rPr>
-              <a:t>  (−) 채용 기간</a:t>
-            </a:r>
-            <a:endParaRPr lang="en-US" sz="750" dirty="0"/>
-          </a:p>
-        </p:txBody>
-      </p:sp>
-      <p:sp>
-        <p:nvSpPr>
-          <p:cNvPr id="56" name="옵션 2"/>
-          <p:cNvSpPr/>
-          <p:nvPr/>
-        </p:nvSpPr>
-        <p:spPr>
-          <a:xfrm>
-            <a:off x="10076688" y="4745736"/>
-            <a:ext cx="1645920" cy="786384"/>
-          </a:xfrm>
-          <a:prstGeom prst="rect">
-            <a:avLst/>
-          </a:prstGeom>
-          <a:solidFill>
-            <a:srgbClr val="FFFFFF"/>
-          </a:solidFill>
-          <a:ln w="9525">
-            <a:solidFill>
-              <a:srgbClr val="A6A6A6"/>
-            </a:solidFill>
-            <a:prstDash val="solid"/>
-          </a:ln>
-        </p:spPr>
-      </p:sp>
-      <p:sp>
-        <p:nvSpPr>
-          <p:cNvPr id="57" name="Text 55"/>
-          <p:cNvSpPr txBox="1"/>
-          <p:nvPr/>
-        </p:nvSpPr>
-        <p:spPr>
-          <a:xfrm>
-            <a:off x="10076688" y="4745736"/>
-            <a:ext cx="1645920" cy="182880"/>
-          </a:xfrm>
-          <a:prstGeom prst="rect">
-            <a:avLst/>
-          </a:prstGeom>
-          <a:solidFill>
-            <a:srgbClr val="595959"/>
-          </a:solidFill>
-          <a:ln/>
-        </p:spPr>
-        <p:txBody>
-          <a:bodyPr wrap="square" lIns="0" tIns="0" rIns="0" bIns="0" rtlCol="0" anchor="ctr"/>
-          <a:lstStyle/>
-          <a:p>
-            <a:pPr algn="ctr" indent="0" marL="0">
-              <a:buNone/>
-            </a:pPr>
-            <a:r>
-              <a:rPr lang="en-US" sz="850" b="1" dirty="0">
-                <a:solidFill>
-                  <a:srgbClr val="FFFFFF"/>
-                </a:solidFill>
-              </a:rPr>
-              <a:t>2안 : 유관부서 협업</a:t>
-            </a:r>
-            <a:endParaRPr lang="en-US" sz="850" dirty="0"/>
-          </a:p>
-        </p:txBody>
-      </p:sp>
-      <p:sp>
-        <p:nvSpPr>
-          <p:cNvPr id="58" name="Text 56"/>
-          <p:cNvSpPr txBox="1"/>
-          <p:nvPr/>
-        </p:nvSpPr>
-        <p:spPr>
-          <a:xfrm>
-            <a:off x="10076688" y="4946904"/>
-            <a:ext cx="1645920" cy="347472"/>
-          </a:xfrm>
-          <a:prstGeom prst="rect">
-            <a:avLst/>
-          </a:prstGeom>
-          <a:noFill/>
-          <a:ln/>
-        </p:spPr>
-        <p:txBody>
-          <a:bodyPr wrap="square" lIns="0" tIns="0" rIns="0" bIns="0" rtlCol="0" anchor="ctr"/>
-          <a:lstStyle/>
-          <a:p>
-            <a:pPr algn="ctr" indent="0" marL="0">
-              <a:buNone/>
-            </a:pPr>
-            <a:r>
-              <a:rPr lang="en-US" sz="900" b="1" dirty="0">
-                <a:solidFill>
-                  <a:srgbClr val="262626"/>
-                </a:solidFill>
-              </a:rPr>
-              <a:t>AI혁신센터·D&amp;AX부문</a:t>
-            </a:r>
-            <a:endParaRPr lang="en-US" sz="900" dirty="0"/>
-          </a:p>
-          <a:p>
-            <a:pPr algn="ctr" indent="0" marL="0">
-              <a:buNone/>
-            </a:pPr>
-            <a:r>
-              <a:rPr lang="en-US" sz="750" dirty="0">
-                <a:solidFill>
-                  <a:srgbClr val="7F7F7F"/>
-                </a:solidFill>
-              </a:rPr>
-              <a:t>AI Agent · Legacy 연동</a:t>
-            </a:r>
-            <a:endParaRPr lang="en-US" sz="900" dirty="0"/>
-          </a:p>
-        </p:txBody>
-      </p:sp>
-      <p:sp>
-        <p:nvSpPr>
-          <p:cNvPr id="59" name="Text 57"/>
-          <p:cNvSpPr txBox="1"/>
-          <p:nvPr/>
-        </p:nvSpPr>
-        <p:spPr>
-          <a:xfrm>
-            <a:off x="10076688" y="5321808"/>
-            <a:ext cx="1645920" cy="182880"/>
-          </a:xfrm>
-          <a:prstGeom prst="rect">
-            <a:avLst/>
-          </a:prstGeom>
-          <a:noFill/>
-          <a:ln/>
-        </p:spPr>
-        <p:txBody>
-          <a:bodyPr wrap="square" lIns="0" tIns="0" rIns="0" bIns="0" rtlCol="0" anchor="ctr"/>
-          <a:lstStyle/>
-          <a:p>
-            <a:pPr algn="ctr" indent="0" marL="0">
-              <a:buNone/>
-            </a:pPr>
-            <a:r>
-              <a:rPr lang="en-US" sz="750" b="1" dirty="0">
-                <a:solidFill>
-                  <a:srgbClr val="2E5C8A"/>
-                </a:solidFill>
-              </a:rPr>
-              <a:t>(+) 즉시 투입</a:t>
-            </a:r>
-            <a:pPr algn="ctr" indent="0" marL="0">
-              <a:buNone/>
-            </a:pPr>
-            <a:r>
-              <a:rPr lang="en-US" sz="750" b="1" dirty="0">
-                <a:solidFill>
-                  <a:srgbClr val="C0392B"/>
-                </a:solidFill>
-              </a:rPr>
-              <a:t>  (−) 일정 조율</a:t>
-            </a:r>
-            <a:endParaRPr lang="en-US" sz="750" dirty="0"/>
-          </a:p>
-        </p:txBody>
-      </p:sp>
-      <p:sp>
-        <p:nvSpPr>
-          <p:cNvPr id="60" name="점선 화살표"/>
-          <p:cNvSpPr/>
-          <p:nvPr/>
-        </p:nvSpPr>
-        <p:spPr>
-          <a:xfrm>
-            <a:off x="8046720" y="4928616"/>
-            <a:ext cx="256032" cy="0"/>
+            <a:off x="7909560" y="5056632"/>
+            <a:ext cx="210312" cy="0"/>
           </a:xfrm>
           <a:prstGeom prst="line">
             <a:avLst/>
@@ -3201,14 +2759,416 @@
       </p:sp>
       <p:sp>
         <p:nvSpPr>
-          <p:cNvPr id="61" name="점선 화살표"/>
+          <p:cNvPr id="49" name="번호 2"/>
           <p:cNvSpPr/>
           <p:nvPr/>
         </p:nvSpPr>
         <p:spPr>
           <a:xfrm>
-            <a:off x="8046720" y="5349240"/>
-            <a:ext cx="256032" cy="0"/>
+            <a:off x="8165592" y="4343400"/>
+            <a:ext cx="201168" cy="201168"/>
+          </a:xfrm>
+          <a:prstGeom prst="ellipse">
+            <a:avLst/>
+          </a:prstGeom>
+          <a:solidFill>
+            <a:srgbClr val="262626"/>
+          </a:solidFill>
+          <a:ln w="12700">
+            <a:solidFill>
+              <a:srgbClr val="262626"/>
+            </a:solidFill>
+            <a:prstDash val="solid"/>
+          </a:ln>
+        </p:spPr>
+      </p:sp>
+      <p:sp>
+        <p:nvSpPr>
+          <p:cNvPr id="50" name="Text 48"/>
+          <p:cNvSpPr txBox="1"/>
+          <p:nvPr/>
+        </p:nvSpPr>
+        <p:spPr>
+          <a:xfrm>
+            <a:off x="8165592" y="4343400"/>
+            <a:ext cx="201168" cy="201168"/>
+          </a:xfrm>
+          <a:prstGeom prst="rect">
+            <a:avLst/>
+          </a:prstGeom>
+          <a:noFill/>
+          <a:ln/>
+        </p:spPr>
+        <p:txBody>
+          <a:bodyPr wrap="square" lIns="0" tIns="0" rIns="0" bIns="0" rtlCol="0" anchor="ctr"/>
+          <a:lstStyle/>
+          <a:p>
+            <a:pPr algn="ctr" indent="0" marL="0">
+              <a:buNone/>
+            </a:pPr>
+            <a:r>
+              <a:rPr lang="en-US" sz="900" b="1" dirty="0">
+                <a:solidFill>
+                  <a:srgbClr val="FFFFFF"/>
+                </a:solidFill>
+              </a:rPr>
+              <a:t>2</a:t>
+            </a:r>
+            <a:endParaRPr lang="en-US" sz="900" dirty="0"/>
+          </a:p>
+        </p:txBody>
+      </p:sp>
+      <p:sp>
+        <p:nvSpPr>
+          <p:cNvPr id="51" name="Text 49"/>
+          <p:cNvSpPr txBox="1"/>
+          <p:nvPr/>
+        </p:nvSpPr>
+        <p:spPr>
+          <a:xfrm>
+            <a:off x="8403336" y="4325112"/>
+            <a:ext cx="1463040" cy="237744"/>
+          </a:xfrm>
+          <a:prstGeom prst="rect">
+            <a:avLst/>
+          </a:prstGeom>
+          <a:noFill/>
+          <a:ln/>
+        </p:spPr>
+        <p:txBody>
+          <a:bodyPr wrap="square" lIns="0" tIns="0" rIns="0" bIns="0" rtlCol="0" anchor="ctr"/>
+          <a:lstStyle/>
+          <a:p>
+            <a:pPr indent="0" marL="0">
+              <a:buNone/>
+            </a:pPr>
+            <a:r>
+              <a:rPr lang="en-US" sz="1000" b="1" dirty="0">
+                <a:solidFill>
+                  <a:srgbClr val="262626"/>
+                </a:solidFill>
+              </a:rPr>
+              <a:t>구현 (Tech 조직)</a:t>
+            </a:r>
+            <a:endParaRPr lang="en-US" sz="1000" dirty="0"/>
+          </a:p>
+        </p:txBody>
+      </p:sp>
+      <p:sp>
+        <p:nvSpPr>
+          <p:cNvPr id="52" name="Tech 그룹"/>
+          <p:cNvSpPr/>
+          <p:nvPr/>
+        </p:nvSpPr>
+        <p:spPr>
+          <a:xfrm>
+            <a:off x="8138160" y="4599432"/>
+            <a:ext cx="2468880" cy="914400"/>
+          </a:xfrm>
+          <a:prstGeom prst="rect">
+            <a:avLst/>
+          </a:prstGeom>
+          <a:solidFill>
+            <a:srgbClr val="FAFAFA"/>
+          </a:solidFill>
+          <a:ln w="9525">
+            <a:solidFill>
+              <a:srgbClr val="BFBFBF"/>
+            </a:solidFill>
+            <a:prstDash val="solid"/>
+          </a:ln>
+        </p:spPr>
+      </p:sp>
+      <p:sp>
+        <p:nvSpPr>
+          <p:cNvPr id="53" name="옵션 라벨 1안"/>
+          <p:cNvSpPr txBox="1"/>
+          <p:nvPr/>
+        </p:nvSpPr>
+        <p:spPr>
+          <a:xfrm>
+            <a:off x="8193024" y="4654296"/>
+            <a:ext cx="658368" cy="384048"/>
+          </a:xfrm>
+          <a:prstGeom prst="rect">
+            <a:avLst/>
+          </a:prstGeom>
+          <a:solidFill>
+            <a:srgbClr val="595959"/>
+          </a:solidFill>
+          <a:ln/>
+        </p:spPr>
+        <p:txBody>
+          <a:bodyPr wrap="square" lIns="0" tIns="0" rIns="0" bIns="0" rtlCol="0" anchor="ctr"/>
+          <a:lstStyle/>
+          <a:p>
+            <a:pPr algn="ctr" indent="0" marL="0">
+              <a:buNone/>
+            </a:pPr>
+            <a:r>
+              <a:rPr lang="en-US" sz="950" b="1" dirty="0">
+                <a:solidFill>
+                  <a:srgbClr val="FFFFFF"/>
+                </a:solidFill>
+              </a:rPr>
+              <a:t>1안</a:t>
+            </a:r>
+            <a:endParaRPr lang="en-US" sz="950" dirty="0"/>
+          </a:p>
+          <a:p>
+            <a:pPr algn="ctr" indent="0" marL="0">
+              <a:buNone/>
+            </a:pPr>
+            <a:r>
+              <a:rPr lang="en-US" sz="650" dirty="0">
+                <a:solidFill>
+                  <a:srgbClr val="FFFFFF"/>
+                </a:solidFill>
+              </a:rPr>
+              <a:t>내부 확보</a:t>
+            </a:r>
+            <a:endParaRPr lang="en-US" sz="950" dirty="0"/>
+          </a:p>
+          <a:p>
+            <a:pPr algn="ctr" indent="0" marL="0">
+              <a:buNone/>
+            </a:pPr>
+            <a:r>
+              <a:rPr lang="en-US" sz="650" dirty="0">
+                <a:solidFill>
+                  <a:srgbClr val="FFFFFF"/>
+                </a:solidFill>
+              </a:rPr>
+              <a:t>(경력 채용)</a:t>
+            </a:r>
+            <a:endParaRPr lang="en-US" sz="950" dirty="0"/>
+          </a:p>
+        </p:txBody>
+      </p:sp>
+      <p:sp>
+        <p:nvSpPr>
+          <p:cNvPr id="54" name="옵션 내용 1안"/>
+          <p:cNvSpPr txBox="1"/>
+          <p:nvPr/>
+        </p:nvSpPr>
+        <p:spPr>
+          <a:xfrm>
+            <a:off x="8887968" y="4654296"/>
+            <a:ext cx="1664208" cy="384048"/>
+          </a:xfrm>
+          <a:prstGeom prst="rect">
+            <a:avLst/>
+          </a:prstGeom>
+          <a:solidFill>
+            <a:srgbClr val="FFFFFF"/>
+          </a:solidFill>
+          <a:ln w="9525">
+            <a:solidFill>
+              <a:srgbClr val="A6A6A6"/>
+            </a:solidFill>
+          </a:ln>
+        </p:spPr>
+        <p:txBody>
+          <a:bodyPr wrap="square" lIns="0" tIns="101600" rIns="101600" bIns="0" rtlCol="0" anchor="ctr"/>
+          <a:lstStyle/>
+          <a:p>
+            <a:pPr algn="l" indent="0" marL="0">
+              <a:buNone/>
+            </a:pPr>
+            <a:r>
+              <a:rPr lang="en-US" sz="950" b="1" dirty="0">
+                <a:solidFill>
+                  <a:srgbClr val="262626"/>
+                </a:solidFill>
+              </a:rPr>
+              <a:t>AI 엔지니어 2명 ('27)</a:t>
+            </a:r>
+            <a:endParaRPr lang="en-US" sz="950" dirty="0"/>
+          </a:p>
+          <a:p>
+            <a:pPr algn="l" indent="0" marL="0">
+              <a:buNone/>
+            </a:pPr>
+            <a:r>
+              <a:rPr lang="en-US" sz="700" dirty="0">
+                <a:solidFill>
+                  <a:srgbClr val="7F7F7F"/>
+                </a:solidFill>
+              </a:rPr>
+              <a:t>MVP 구현 · 협업 조직 연결</a:t>
+            </a:r>
+            <a:endParaRPr lang="en-US" sz="950" dirty="0"/>
+          </a:p>
+        </p:txBody>
+      </p:sp>
+      <p:sp>
+        <p:nvSpPr>
+          <p:cNvPr id="55" name="옵션 라벨 2안"/>
+          <p:cNvSpPr txBox="1"/>
+          <p:nvPr/>
+        </p:nvSpPr>
+        <p:spPr>
+          <a:xfrm>
+            <a:off x="8193024" y="5074920"/>
+            <a:ext cx="658368" cy="384048"/>
+          </a:xfrm>
+          <a:prstGeom prst="rect">
+            <a:avLst/>
+          </a:prstGeom>
+          <a:solidFill>
+            <a:srgbClr val="2E5C8A"/>
+          </a:solidFill>
+          <a:ln/>
+        </p:spPr>
+        <p:txBody>
+          <a:bodyPr wrap="square" lIns="0" tIns="0" rIns="0" bIns="0" rtlCol="0" anchor="ctr"/>
+          <a:lstStyle/>
+          <a:p>
+            <a:pPr algn="ctr" indent="0" marL="0">
+              <a:buNone/>
+            </a:pPr>
+            <a:r>
+              <a:rPr lang="en-US" sz="950" b="1" dirty="0">
+                <a:solidFill>
+                  <a:srgbClr val="FFFFFF"/>
+                </a:solidFill>
+              </a:rPr>
+              <a:t>2안</a:t>
+            </a:r>
+            <a:endParaRPr lang="en-US" sz="950" dirty="0"/>
+          </a:p>
+          <a:p>
+            <a:pPr algn="ctr" indent="0" marL="0">
+              <a:buNone/>
+            </a:pPr>
+            <a:r>
+              <a:rPr lang="en-US" sz="650" dirty="0">
+                <a:solidFill>
+                  <a:srgbClr val="FFFFFF"/>
+                </a:solidFill>
+              </a:rPr>
+              <a:t>협업</a:t>
+            </a:r>
+            <a:endParaRPr lang="en-US" sz="950" dirty="0"/>
+          </a:p>
+          <a:p>
+            <a:pPr algn="ctr" indent="0" marL="0">
+              <a:buNone/>
+            </a:pPr>
+            <a:r>
+              <a:rPr lang="en-US" sz="650" dirty="0">
+                <a:solidFill>
+                  <a:srgbClr val="FFFFFF"/>
+                </a:solidFill>
+              </a:rPr>
+              <a:t>(유관부서)</a:t>
+            </a:r>
+            <a:endParaRPr lang="en-US" sz="950" dirty="0"/>
+          </a:p>
+        </p:txBody>
+      </p:sp>
+      <p:sp>
+        <p:nvSpPr>
+          <p:cNvPr id="56" name="옵션 내용 2안"/>
+          <p:cNvSpPr txBox="1"/>
+          <p:nvPr/>
+        </p:nvSpPr>
+        <p:spPr>
+          <a:xfrm>
+            <a:off x="8887968" y="5074920"/>
+            <a:ext cx="1664208" cy="384048"/>
+          </a:xfrm>
+          <a:prstGeom prst="rect">
+            <a:avLst/>
+          </a:prstGeom>
+          <a:solidFill>
+            <a:srgbClr val="FFFFFF"/>
+          </a:solidFill>
+          <a:ln w="9525">
+            <a:solidFill>
+              <a:srgbClr val="A6A6A6"/>
+            </a:solidFill>
+          </a:ln>
+        </p:spPr>
+        <p:txBody>
+          <a:bodyPr wrap="square" lIns="0" tIns="101600" rIns="101600" bIns="0" rtlCol="0" anchor="ctr"/>
+          <a:lstStyle/>
+          <a:p>
+            <a:pPr algn="l" indent="0" marL="0">
+              <a:buNone/>
+            </a:pPr>
+            <a:r>
+              <a:rPr lang="en-US" sz="950" b="1" dirty="0">
+                <a:solidFill>
+                  <a:srgbClr val="262626"/>
+                </a:solidFill>
+              </a:rPr>
+              <a:t>AI혁신센터 + D&amp;AX부문</a:t>
+            </a:r>
+            <a:endParaRPr lang="en-US" sz="950" dirty="0"/>
+          </a:p>
+          <a:p>
+            <a:pPr algn="l" indent="0" marL="0">
+              <a:buNone/>
+            </a:pPr>
+            <a:r>
+              <a:rPr lang="en-US" sz="700" dirty="0">
+                <a:solidFill>
+                  <a:srgbClr val="7F7F7F"/>
+                </a:solidFill>
+              </a:rPr>
+              <a:t>AI Agent · Legacy 연동 · 구축사업</a:t>
+            </a:r>
+            <a:endParaRPr lang="en-US" sz="950" dirty="0"/>
+          </a:p>
+        </p:txBody>
+      </p:sp>
+      <p:sp>
+        <p:nvSpPr>
+          <p:cNvPr id="57" name="Text 55"/>
+          <p:cNvSpPr txBox="1"/>
+          <p:nvPr/>
+        </p:nvSpPr>
+        <p:spPr>
+          <a:xfrm>
+            <a:off x="8138160" y="5532120"/>
+            <a:ext cx="2468880" cy="182880"/>
+          </a:xfrm>
+          <a:prstGeom prst="rect">
+            <a:avLst/>
+          </a:prstGeom>
+          <a:noFill/>
+          <a:ln/>
+        </p:spPr>
+        <p:txBody>
+          <a:bodyPr wrap="square" lIns="0" tIns="0" rIns="0" bIns="0" rtlCol="0" anchor="ctr"/>
+          <a:lstStyle/>
+          <a:p>
+            <a:pPr algn="ctr" indent="0" marL="0">
+              <a:buNone/>
+            </a:pPr>
+            <a:r>
+              <a:rPr lang="en-US" sz="850" b="1" dirty="0">
+                <a:solidFill>
+                  <a:srgbClr val="2E5C8A"/>
+                </a:solidFill>
+              </a:rPr>
+              <a:t>★ 추천 : 2안으로 즉시 착수 → 1안으로 내재화</a:t>
+            </a:r>
+            <a:endParaRPr lang="en-US" sz="850" dirty="0"/>
+          </a:p>
+        </p:txBody>
+      </p:sp>
+      <p:sp>
+        <p:nvSpPr>
+          <p:cNvPr id="58" name="점선 화살표"/>
+          <p:cNvSpPr/>
+          <p:nvPr/>
+        </p:nvSpPr>
+        <p:spPr>
+          <a:xfrm>
+            <a:off x="10625328" y="5056632"/>
+            <a:ext cx="237744" cy="0"/>
           </a:xfrm>
           <a:prstGeom prst="line">
             <a:avLst/>
@@ -3225,13 +3185,182 @@
       </p:sp>
       <p:sp>
         <p:nvSpPr>
-          <p:cNvPr id="62" name="머리표 기대효과"/>
+          <p:cNvPr id="59" name="번호 3"/>
           <p:cNvSpPr/>
           <p:nvPr/>
         </p:nvSpPr>
         <p:spPr>
           <a:xfrm>
-            <a:off x="6336792" y="5733288"/>
+            <a:off x="10817352" y="4343400"/>
+            <a:ext cx="201168" cy="201168"/>
+          </a:xfrm>
+          <a:prstGeom prst="ellipse">
+            <a:avLst/>
+          </a:prstGeom>
+          <a:solidFill>
+            <a:srgbClr val="262626"/>
+          </a:solidFill>
+          <a:ln w="12700">
+            <a:solidFill>
+              <a:srgbClr val="262626"/>
+            </a:solidFill>
+            <a:prstDash val="solid"/>
+          </a:ln>
+        </p:spPr>
+      </p:sp>
+      <p:sp>
+        <p:nvSpPr>
+          <p:cNvPr id="60" name="Text 58"/>
+          <p:cNvSpPr txBox="1"/>
+          <p:nvPr/>
+        </p:nvSpPr>
+        <p:spPr>
+          <a:xfrm>
+            <a:off x="10817352" y="4343400"/>
+            <a:ext cx="201168" cy="201168"/>
+          </a:xfrm>
+          <a:prstGeom prst="rect">
+            <a:avLst/>
+          </a:prstGeom>
+          <a:noFill/>
+          <a:ln/>
+        </p:spPr>
+        <p:txBody>
+          <a:bodyPr wrap="square" lIns="0" tIns="0" rIns="0" bIns="0" rtlCol="0" anchor="ctr"/>
+          <a:lstStyle/>
+          <a:p>
+            <a:pPr algn="ctr" indent="0" marL="0">
+              <a:buNone/>
+            </a:pPr>
+            <a:r>
+              <a:rPr lang="en-US" sz="900" b="1" dirty="0">
+                <a:solidFill>
+                  <a:srgbClr val="FFFFFF"/>
+                </a:solidFill>
+              </a:rPr>
+              <a:t>3</a:t>
+            </a:r>
+            <a:endParaRPr lang="en-US" sz="900" dirty="0"/>
+          </a:p>
+        </p:txBody>
+      </p:sp>
+      <p:sp>
+        <p:nvSpPr>
+          <p:cNvPr id="61" name="Text 59"/>
+          <p:cNvSpPr txBox="1"/>
+          <p:nvPr/>
+        </p:nvSpPr>
+        <p:spPr>
+          <a:xfrm>
+            <a:off x="11055096" y="4325112"/>
+            <a:ext cx="914400" cy="237744"/>
+          </a:xfrm>
+          <a:prstGeom prst="rect">
+            <a:avLst/>
+          </a:prstGeom>
+          <a:noFill/>
+          <a:ln/>
+        </p:spPr>
+        <p:txBody>
+          <a:bodyPr wrap="square" lIns="0" tIns="0" rIns="0" bIns="0" rtlCol="0" anchor="ctr"/>
+          <a:lstStyle/>
+          <a:p>
+            <a:pPr indent="0" marL="0">
+              <a:buNone/>
+            </a:pPr>
+            <a:r>
+              <a:rPr lang="en-US" sz="1000" b="1" dirty="0">
+                <a:solidFill>
+                  <a:srgbClr val="262626"/>
+                </a:solidFill>
+              </a:rPr>
+              <a:t>운영 이관</a:t>
+            </a:r>
+            <a:endParaRPr lang="en-US" sz="1000" dirty="0"/>
+          </a:p>
+        </p:txBody>
+      </p:sp>
+      <p:sp>
+        <p:nvSpPr>
+          <p:cNvPr id="62" name="그룹사"/>
+          <p:cNvSpPr txBox="1"/>
+          <p:nvPr/>
+        </p:nvSpPr>
+        <p:spPr>
+          <a:xfrm>
+            <a:off x="10881360" y="4599432"/>
+            <a:ext cx="914400" cy="914400"/>
+          </a:xfrm>
+          <a:prstGeom prst="roundRect">
+            <a:avLst>
+              <a:gd name="adj" fmla="val 6000"/>
+            </a:avLst>
+          </a:prstGeom>
+          <a:solidFill>
+            <a:srgbClr val="FFFFFF"/>
+          </a:solidFill>
+          <a:ln w="12700">
+            <a:solidFill>
+              <a:srgbClr val="2E5C8A"/>
+            </a:solidFill>
+          </a:ln>
+        </p:spPr>
+        <p:txBody>
+          <a:bodyPr wrap="square" lIns="0" tIns="0" rIns="0" bIns="0" rtlCol="0" anchor="ctr"/>
+          <a:lstStyle/>
+          <a:p>
+            <a:pPr algn="ctr" indent="0" marL="0">
+              <a:buNone/>
+            </a:pPr>
+            <a:r>
+              <a:rPr lang="en-US" sz="1050" b="1" dirty="0">
+                <a:solidFill>
+                  <a:srgbClr val="262626"/>
+                </a:solidFill>
+              </a:rPr>
+              <a:t>그룹사</a:t>
+            </a:r>
+            <a:endParaRPr lang="en-US" sz="1050" dirty="0"/>
+          </a:p>
+          <a:p>
+            <a:pPr algn="ctr" indent="0" marL="0">
+              <a:buNone/>
+            </a:pPr>
+            <a:r>
+              <a:rPr lang="en-US" sz="850" b="1" dirty="0">
+                <a:solidFill>
+                  <a:srgbClr val="262626"/>
+                </a:solidFill>
+              </a:rPr>
+              <a:t>현장 적용</a:t>
+            </a:r>
+            <a:endParaRPr lang="en-US" sz="1050" dirty="0"/>
+          </a:p>
+          <a:p>
+            <a:pPr algn="ctr" indent="0" marL="0">
+              <a:buNone/>
+            </a:pPr>
+            <a:r>
+              <a:rPr lang="en-US" sz="750" b="1" dirty="0">
+                <a:solidFill>
+                  <a:srgbClr val="2E5C8A"/>
+                </a:solidFill>
+              </a:rPr>
+              <a:t>MVP → 구축사업</a:t>
+            </a:r>
+            <a:endParaRPr lang="en-US" sz="1050" dirty="0"/>
+          </a:p>
+        </p:txBody>
+      </p:sp>
+      <p:sp>
+        <p:nvSpPr>
+          <p:cNvPr id="63" name="머리표 기대효과"/>
+          <p:cNvSpPr/>
+          <p:nvPr/>
+        </p:nvSpPr>
+        <p:spPr>
+          <a:xfrm>
+            <a:off x="6336792" y="5824728"/>
             <a:ext cx="155448" cy="155448"/>
           </a:xfrm>
           <a:prstGeom prst="rect">
@@ -3257,13 +3386,13 @@
       </p:sp>
       <p:sp>
         <p:nvSpPr>
-          <p:cNvPr id="63" name="Text 61"/>
-          <p:cNvSpPr txBox="1"/>
-          <p:nvPr/>
-        </p:nvSpPr>
-        <p:spPr>
-          <a:xfrm>
-            <a:off x="6565392" y="5669280"/>
+          <p:cNvPr id="64" name="Text 62"/>
+          <p:cNvSpPr txBox="1"/>
+          <p:nvPr/>
+        </p:nvSpPr>
+        <p:spPr>
+          <a:xfrm>
+            <a:off x="6565392" y="5760720"/>
             <a:ext cx="5230368" cy="283464"/>
           </a:xfrm>
           <a:prstGeom prst="rect">
@@ -3293,13 +3422,13 @@
       </p:sp>
       <p:sp>
         <p:nvSpPr>
-          <p:cNvPr id="64" name="Text 62"/>
-          <p:cNvSpPr txBox="1"/>
-          <p:nvPr/>
-        </p:nvSpPr>
-        <p:spPr>
-          <a:xfrm>
-            <a:off x="7525512" y="5678424"/>
+          <p:cNvPr id="65" name="Text 63"/>
+          <p:cNvSpPr txBox="1"/>
+          <p:nvPr/>
+        </p:nvSpPr>
+        <p:spPr>
+          <a:xfrm>
+            <a:off x="7525512" y="5769864"/>
             <a:ext cx="868680" cy="210312"/>
           </a:xfrm>
           <a:prstGeom prst="rect">
@@ -3331,13 +3460,13 @@
       </p:sp>
       <p:sp>
         <p:nvSpPr>
-          <p:cNvPr id="65" name="Text 63"/>
-          <p:cNvSpPr txBox="1"/>
-          <p:nvPr/>
-        </p:nvSpPr>
-        <p:spPr>
-          <a:xfrm>
-            <a:off x="8485632" y="5669280"/>
+          <p:cNvPr id="66" name="Text 64"/>
+          <p:cNvSpPr txBox="1"/>
+          <p:nvPr/>
+        </p:nvSpPr>
+        <p:spPr>
+          <a:xfrm>
+            <a:off x="8485632" y="5760720"/>
             <a:ext cx="3337560" cy="228600"/>
           </a:xfrm>
           <a:prstGeom prst="rect">
@@ -3367,13 +3496,13 @@
       </p:sp>
       <p:sp>
         <p:nvSpPr>
-          <p:cNvPr id="66" name="Text 64"/>
-          <p:cNvSpPr txBox="1"/>
-          <p:nvPr/>
-        </p:nvSpPr>
-        <p:spPr>
-          <a:xfrm>
-            <a:off x="7525512" y="5925312"/>
+          <p:cNvPr id="67" name="Text 65"/>
+          <p:cNvSpPr txBox="1"/>
+          <p:nvPr/>
+        </p:nvSpPr>
+        <p:spPr>
+          <a:xfrm>
+            <a:off x="7525512" y="5989320"/>
             <a:ext cx="868680" cy="210312"/>
           </a:xfrm>
           <a:prstGeom prst="rect">
@@ -3405,13 +3534,13 @@
       </p:sp>
       <p:sp>
         <p:nvSpPr>
-          <p:cNvPr id="67" name="Text 65"/>
-          <p:cNvSpPr txBox="1"/>
-          <p:nvPr/>
-        </p:nvSpPr>
-        <p:spPr>
-          <a:xfrm>
-            <a:off x="8485632" y="5916168"/>
+          <p:cNvPr id="68" name="Text 66"/>
+          <p:cNvSpPr txBox="1"/>
+          <p:nvPr/>
+        </p:nvSpPr>
+        <p:spPr>
+          <a:xfrm>
+            <a:off x="8485632" y="5980176"/>
             <a:ext cx="3337560" cy="228600"/>
           </a:xfrm>
           <a:prstGeom prst="rect">
@@ -3441,13 +3570,13 @@
       </p:sp>
       <p:sp>
         <p:nvSpPr>
-          <p:cNvPr id="68" name="Text 66"/>
-          <p:cNvSpPr txBox="1"/>
-          <p:nvPr/>
-        </p:nvSpPr>
-        <p:spPr>
-          <a:xfrm>
-            <a:off x="7525512" y="6172200"/>
+          <p:cNvPr id="69" name="Text 67"/>
+          <p:cNvSpPr txBox="1"/>
+          <p:nvPr/>
+        </p:nvSpPr>
+        <p:spPr>
+          <a:xfrm>
+            <a:off x="7525512" y="6208776"/>
             <a:ext cx="868680" cy="210312"/>
           </a:xfrm>
           <a:prstGeom prst="rect">
@@ -3479,13 +3608,13 @@
       </p:sp>
       <p:sp>
         <p:nvSpPr>
-          <p:cNvPr id="69" name="Text 67"/>
-          <p:cNvSpPr txBox="1"/>
-          <p:nvPr/>
-        </p:nvSpPr>
-        <p:spPr>
-          <a:xfrm>
-            <a:off x="8485632" y="6163056"/>
+          <p:cNvPr id="70" name="Text 68"/>
+          <p:cNvSpPr txBox="1"/>
+          <p:nvPr/>
+        </p:nvSpPr>
+        <p:spPr>
+          <a:xfrm>
+            <a:off x="8485632" y="6199632"/>
             <a:ext cx="3337560" cy="228600"/>
           </a:xfrm>
           <a:prstGeom prst="rect">

</xml_diff>